<commit_message>
Send one Critical bug email with screenshots whenever a run detects Critical bugs
- When a test run ends and any Critical bug was detected (new or already
  known), one email goes to every address in ALERT_TO with each Critical
  bug's details, full error and an inline screenshot; no Critical bug means
  no email. The pipeline sends one email for all its runs, report attached
- New bug_occurrences table records every run in which a bug was seen
- Shared email delivery with HTML preview fallback in reports/alerts/
- README, walkthrough and presentation slide 15 updated

Co-Authored-By: Claude Opus 5.5 <noreply@anthropic.com>
</commit_message>
<xml_diff>
--- a/presentation/Automated_Bug_Reporting_Presentation.pptx
+++ b/presentation/Automated_Bug_Reporting_Presentation.pptx
@@ -3560,7 +3560,7 @@
           <a:p>
             <a:r>
               <a:rPr lang="en-US" dirty="0"/>
-              <a:t>When the model predicts Critical for a new bug, Nodemailer sends an email over SMTP with the bug details, a link to the dashboard and the screenshot attached. Repeat failures of the same bug do not send new emails. Without SMTP settings, the same email is saved as an HTML preview so the feature can still be demonstrated.</a:t>
+              <a:t>Whenever a test run ends and at least one Critical bug was detected, new or already known, one email goes to every address configured in the .env file. For each Critical bug it shows the module, the test, the error and a clear screenshot of the page at the moment of failure, embedded in the email. A run without Critical bugs sends nothing, so the email always means something urgent. The pipeline sends one email covering all its runs, with the full report attached. Without SMTP settings the same email is saved as an HTML preview.</a:t>
             </a:r>
             <a:endParaRPr lang="en-US" dirty="0"/>
           </a:p>
@@ -11198,7 +11198,7 @@
                   <a:schemeClr val="tx2"/>
                 </a:solidFill>
               </a:rPr>
-              <a:t>ML predicts Critical</a:t>
+              <a:t>Run ends with a Critical bug</a:t>
             </a:r>
             <a:endParaRPr lang="en-US" sz="1800" dirty="0"/>
           </a:p>
@@ -11234,7 +11234,7 @@
                   <a:schemeClr val="tx1"/>
                 </a:solidFill>
               </a:rPr>
-              <a:t>for a newly detected bug</a:t>
+              <a:t>new or already known, in any module</a:t>
             </a:r>
             <a:endParaRPr lang="en-US" sz="1500" dirty="0"/>
           </a:p>
@@ -11332,7 +11332,7 @@
                   <a:schemeClr val="tx2"/>
                 </a:solidFill>
               </a:rPr>
-              <a:t>Nodemailer sends the email</a:t>
+              <a:t>One email to every address in .env</a:t>
             </a:r>
             <a:endParaRPr lang="en-US" sz="1800" dirty="0"/>
           </a:p>
@@ -11368,7 +11368,7 @@
                   <a:schemeClr val="tx1"/>
                 </a:solidFill>
               </a:rPr>
-              <a:t>SMTP, e.g. Gmail with an App Password</a:t>
+              <a:t>Nodemailer via SMTP (Gmail App Password)</a:t>
             </a:r>
             <a:endParaRPr lang="en-US" sz="1500" dirty="0"/>
           </a:p>
@@ -11466,7 +11466,7 @@
                   <a:schemeClr val="tx2"/>
                 </a:solidFill>
               </a:rPr>
-              <a:t>Team is notified</a:t>
+              <a:t>Clear snapshot of each Critical bug</a:t>
             </a:r>
             <a:endParaRPr lang="en-US" sz="1800" dirty="0"/>
           </a:p>
@@ -11502,7 +11502,7 @@
                   <a:schemeClr val="tx1"/>
                 </a:solidFill>
               </a:rPr>
-              <a:t>details, dashboard link, screenshot attached</a:t>
+              <a:t>error, details and screenshot inside the email</a:t>
             </a:r>
             <a:endParaRPr lang="en-US" sz="1500" dirty="0"/>
           </a:p>
@@ -11564,7 +11564,7 @@
                   <a:schemeClr val="tx1"/>
                 </a:solidFill>
               </a:rPr>
-              <a:t>Sent once per new Critical bug, never again for repeats</a:t>
+              <a:t>No Critical bug in the run = no email</a:t>
             </a:r>
             <a:endParaRPr lang="en-US" sz="1400" dirty="0"/>
           </a:p>

</xml_diff>

<commit_message>
Headed runs, re-run of failed tests, Critical-only email default, simpler analytics
- Test Runner runs in headed mode by default (visible browser, one test at a
  time); switch to turn it off
- Re-run failed tests: "Re-run N failed tests" and a Re-run button on every
  failed test re-run exactly those tests (file:line) with the same settings
- Report email is sent only if a Critical bug is found by default; clear red
  NOT SENT warnings when no sending account is set in .env, which is re-read
  before every email (no restart needed); friendlier mail errors
- Analytics page simplified: four key numbers, bugs per module, bugs by
  severity and a 14-day trend in plain HTML/CSS (Chart.js removed)
- Playwright is started directly through Node for UI runs
- README (manual testing of ShopEase, launcher tips), walkthrough and
  presentation (slides 6, 17, 18) updated

Co-Authored-By: Claude Opus 5.5 <noreply@anthropic.com>
</commit_message>
<xml_diff>
--- a/presentation/Automated_Bug_Reporting_Presentation.pptx
+++ b/presentation/Automated_Bug_Reporting_Presentation.pptx
@@ -4092,7 +4092,7 @@
           <a:p>
             <a:r>
               <a:rPr lang="en-US" dirty="0"/>
-              <a:t>The manager asked that manual testers can run the automation without VS Code. This is the Test Runner: a web page with a suite dropdown, an email box and a Run button. The tester double-clicks Start Test Runner, chooses Smoke, Sanity, Regression or Broken links, types the email addresses and presses Run. The server starts Playwright with the suite tag, the page shows live progress, and when the run ends the report opens in the same page and is emailed to the people entered. Every run is kept in the run history with the date as prefix.</a:t>
+              <a:t>The manager asked that manual testers can run the automation without VS Code. This is the Test Runner. The tester double-clicks Start Test Runner, the page opens, and nothing runs until they choose Smoke, Sanity, Regression or Broken links and press Run. In headed mode a browser window opens and every test can be watched, one at a time, while the page shows live progress. When the run ends the report opens in the same page, and if a Critical bug was found it is emailed to the addresses entered. Every run is kept in the run history with the date as prefix.</a:t>
             </a:r>
             <a:endParaRPr lang="en-US" dirty="0"/>
           </a:p>
@@ -4180,7 +4180,7 @@
           <a:p>
             <a:r>
               <a:rPr lang="en-US" dirty="0"/>
-              <a:t>This is the report of a Regression run, shown in the same UI. At the top: the run name with the date first, the status, suite, duration and who received the email. Then the pass rate, the totals, results by module and bugs by severity, with the Critical bugs called out. Below, every test is listed by module; clicking a failed test shows its error, its ML severity and the screenshot. The report can be downloaded as one self-contained HTML file, it is emailed automatically, and it stays in the run history.</a:t>
+              <a:t>This is the report of a run, shown in the same UI. At the top: the run name with the date first, the status, suite, duration and the email status. Then the pass rate, the totals, results by module and bugs by severity, with the Critical bugs called out. Below, every test is listed by module; clicking a failed test shows its error, its ML severity and the screenshot, and its Re-run button runs just that test again. Re-run failed tests runs all failed tests of that run. The report can be downloaded as one HTML file and stays in the run history.</a:t>
             </a:r>
             <a:endParaRPr lang="en-US" dirty="0"/>
           </a:p>
@@ -16232,7 +16232,7 @@
                   <a:schemeClr val="tx1"/>
                 </a:solidFill>
               </a:rPr>
-              <a:t>Report emailed when the run ends</a:t>
+              <a:t>Emailed when a Critical bug is found</a:t>
             </a:r>
             <a:endParaRPr lang="en-US" sz="1400" dirty="0"/>
           </a:p>
@@ -16348,7 +16348,7 @@
                   <a:schemeClr val="tx1"/>
                 </a:solidFill>
               </a:rPr>
-              <a:t>Live progress, report in the same UI</a:t>
+              <a:t>Headed browser, live progress, report</a:t>
             </a:r>
             <a:endParaRPr lang="en-US" sz="1400" dirty="0"/>
           </a:p>
@@ -17100,7 +17100,7 @@
                   <a:schemeClr val="tx1"/>
                 </a:solidFill>
               </a:rPr>
-              <a:t>Error, ML severity and screenshot</a:t>
+              <a:t>Error, screenshot, one-click Re-run</a:t>
             </a:r>
             <a:endParaRPr lang="en-US" sz="1400" dirty="0"/>
           </a:p>
@@ -21349,7 +21349,7 @@
                   <a:schemeClr val="tx2"/>
                 </a:solidFill>
               </a:rPr>
-              <a:t>Chart.js 4.5</a:t>
+              <a:t>HTML/CSS charts</a:t>
             </a:r>
             <a:endParaRPr lang="en-US" sz="1900" dirty="0"/>
           </a:p>
@@ -21385,7 +21385,7 @@
                   <a:schemeClr val="tx1"/>
                 </a:solidFill>
               </a:rPr>
-              <a:t>Module, severity and trend charts</a:t>
+              <a:t>Light, no chart library needed</a:t>
             </a:r>
             <a:endParaRPr lang="en-US" sz="1500" dirty="0"/>
           </a:p>

</xml_diff>